<commit_message>
Bring all documentation up to date with the predictive enemy
The code shipped two commits ago but the docs did not follow it. README and
the code walkthrough did not mention the feature at all, and Akhil's
presenter pack still told him to present the predictive enemy as future
work, which would have been wrong on stage.

- README: approach section and file tree updated, test count corrected
- CODE_WALKTHROUGH: new section on PredictiveEnemy covering both stages,
  the measured interception rates, and the two bugs it produced
- AKHIL.md: the feature added to his code section with the numbers he will
  be asked for, and slide 5 rewritten from "future scope" to presenting
  his own build, with the follow-up questions
- Slide 5 of the PPTX rebuilt to match, with the interception screenshot
- Study guide and all four presenter PDFs regenerated
- Filled Annexure B added

Co-Authored-By: Claude Opus 5 <noreply@anthropic.com>
</commit_message>
<xml_diff>
--- a/docs/MazeRunner_Slides.pptx
+++ b/docs/MazeRunner_Slides.pptx
@@ -786,7 +786,7 @@
           <a:lstStyle/>
           <a:p>
             <a:r>
-              <a:t>AKHIL — 40 seconds. Pick ONE item, don't read all four. Best is the predictive enemy, because it names a real limitation: the enemy always trails, it never intercepts. 'With more time we'd have it path to where you're heading, so it could cut you off at a junction. That's a different problem - you have to predict intent, not just compute a route.' Then close cleanly and STOP: 'That's our project. Code and documentation are on GitHub. Happy to take questions.'</a:t>
+              <a:t>AKHIL - 60 seconds. This is YOUR feature, so take it properly. The other enemies path to where the player IS, so they always trail. This one predicts where you're going and gets there first. Stage one: it walks forward along your heading and STOPS at junctions - that honesty is the interesting bit, it refuses to guess where it cannot know. Stage two: one flood fill, then the deepest cell on that route it can reach before you - the yellow box. Then the trade-off: ~721 cells of thinking per step against BFS's 328, so it pays for the ability. If asked how often it works: 23-32% within 20 cells, never beyond about 30, because the lookahead bounds how far ahead it can commit. Close: 'That's our project. Code and documentation are on GitHub. Happy to take questions.'</a:t>
             </a:r>
           </a:p>
         </p:txBody>
@@ -6457,7 +6457,7 @@
     <p:bg>
       <p:bgPr>
         <a:solidFill>
-          <a:srgbClr val="56CCF2"/>
+          <a:srgbClr val="121218"/>
         </a:solidFill>
         <a:effectLst/>
       </p:bgPr>
@@ -6477,8 +6477,8 @@
         </p:nvSpPr>
         <p:spPr>
           <a:xfrm>
-            <a:off x="777240" y="685800"/>
-            <a:ext cx="10637215" cy="1371600"/>
+            <a:off x="777240" y="566928"/>
+            <a:ext cx="10637215" cy="1280160"/>
           </a:xfrm>
           <a:prstGeom prst="rect">
             <a:avLst/>
@@ -6497,13 +6497,13 @@
               </a:spcAft>
               <a:defRPr sz="1300" b="0">
                 <a:solidFill>
-                  <a:srgbClr val="15506B"/>
+                  <a:srgbClr val="9B59B6"/>
                 </a:solidFill>
                 <a:latin typeface="Consolas"/>
               </a:defRPr>
             </a:pPr>
             <a:r>
-              <a:t>FUTURE SCOPE</a:t>
+              <a:t>BEYOND THE BRIEF</a:t>
             </a:r>
           </a:p>
           <a:p>
@@ -6511,65 +6511,43 @@
               <a:spcAft>
                 <a:spcPts val="0"/>
               </a:spcAft>
-              <a:defRPr sz="4000" b="1">
-                <a:solidFill>
-                  <a:srgbClr val="121218"/>
+              <a:defRPr sz="3800" b="1">
+                <a:solidFill>
+                  <a:srgbClr val="F2F2F7"/>
                 </a:solidFill>
                 <a:latin typeface="Segoe UI"/>
               </a:defRPr>
             </a:pPr>
             <a:r>
-              <a:t>What we would build next</a:t>
-            </a:r>
-          </a:p>
-        </p:txBody>
-      </p:sp>
-      <p:sp>
-        <p:nvSpPr>
-          <p:cNvPr id="3" name="Rounded Rectangle 2"/>
-          <p:cNvSpPr/>
+              <a:t>An enemy that cuts you off</a:t>
+            </a:r>
+          </a:p>
+        </p:txBody>
+      </p:sp>
+      <p:pic>
+        <p:nvPicPr>
+          <p:cNvPr id="3" name="Picture 2" descr="demo_intercept.png"/>
+          <p:cNvPicPr>
+            <a:picLocks noChangeAspect="1"/>
+          </p:cNvPicPr>
           <p:nvPr/>
-        </p:nvSpPr>
-        <p:spPr>
-          <a:xfrm>
-            <a:off x="777240" y="2514600"/>
-            <a:ext cx="2508427" cy="2286000"/>
-          </a:xfrm>
-          <a:prstGeom prst="roundRect">
-            <a:avLst>
-              <a:gd name="adj" fmla="val 6000"/>
-            </a:avLst>
+        </p:nvPicPr>
+        <p:blipFill>
+          <a:blip r:embed="rId2"/>
+          <a:stretch>
+            <a:fillRect/>
+          </a:stretch>
+        </p:blipFill>
+        <p:spPr>
+          <a:xfrm>
+            <a:off x="777240" y="2057400"/>
+            <a:ext cx="6035040" cy="4291332"/>
+          </a:xfrm>
+          <a:prstGeom prst="rect">
+            <a:avLst/>
           </a:prstGeom>
-          <a:solidFill>
-            <a:srgbClr val="EAF8FE"/>
-          </a:solidFill>
-          <a:ln w="12700">
-            <a:solidFill>
-              <a:srgbClr val="8FD9F5"/>
-            </a:solidFill>
-          </a:ln>
-          <a:effectLst/>
-        </p:spPr>
-        <p:style>
-          <a:lnRef idx="1">
-            <a:schemeClr val="accent1"/>
-          </a:lnRef>
-          <a:fillRef idx="3">
-            <a:schemeClr val="accent1"/>
-          </a:fillRef>
-          <a:effectRef idx="2">
-            <a:schemeClr val="accent1"/>
-          </a:effectRef>
-          <a:fontRef idx="minor">
-            <a:schemeClr val="lt1"/>
-          </a:fontRef>
-        </p:style>
-        <p:txBody>
-          <a:bodyPr rtlCol="0" anchor="ctr"/>
-          <a:lstStyle/>
-          <a:p/>
-        </p:txBody>
-      </p:sp>
+        </p:spPr>
+      </p:pic>
       <p:sp>
         <p:nvSpPr>
           <p:cNvPr id="4" name="TextBox 3"/>
@@ -6578,8 +6556,8 @@
         </p:nvSpPr>
         <p:spPr>
           <a:xfrm>
-            <a:off x="1033272" y="2743200"/>
-            <a:ext cx="1996363" cy="1920240"/>
+            <a:off x="7132320" y="2057400"/>
+            <a:ext cx="4282135" cy="822960"/>
           </a:xfrm>
           <a:prstGeom prst="rect">
             <a:avLst/>
@@ -6591,22 +6569,6 @@
             <a:spAutoFit/>
           </a:bodyPr>
           <a:lstStyle/>
-          <a:p>
-            <a:pPr>
-              <a:spcAft>
-                <a:spcPts val="700"/>
-              </a:spcAft>
-              <a:defRPr sz="1500" b="1">
-                <a:solidFill>
-                  <a:srgbClr val="121218"/>
-                </a:solidFill>
-                <a:latin typeface="Segoe UI"/>
-              </a:defRPr>
-            </a:pPr>
-            <a:r>
-              <a:t>A predictive enemy</a:t>
-            </a:r>
-          </a:p>
           <a:p>
             <a:pPr>
               <a:lnSpc>
@@ -6615,15 +6577,15 @@
               <a:spcAft>
                 <a:spcPts val="0"/>
               </a:spcAft>
-              <a:defRPr sz="1200" b="0">
-                <a:solidFill>
-                  <a:srgbClr val="2C3A44"/>
+              <a:defRPr sz="1400" b="0">
+                <a:solidFill>
+                  <a:srgbClr val="C9CEDA"/>
                 </a:solidFill>
                 <a:latin typeface="Segoe UI"/>
               </a:defRPr>
             </a:pPr>
             <a:r>
-              <a:t>Right now it chases where you are. An enemy that paths to where you are heading could cut you off at a junction instead of trailing you.</a:t>
+              <a:t>The other enemies path to where you ARE, so they always trail. This one asks where you will BE.</a:t>
             </a:r>
           </a:p>
         </p:txBody>
@@ -6636,8 +6598,8 @@
         </p:nvSpPr>
         <p:spPr>
           <a:xfrm>
-            <a:off x="3486835" y="2514600"/>
-            <a:ext cx="2508427" cy="2286000"/>
+            <a:off x="7132320" y="3063240"/>
+            <a:ext cx="4282135" cy="1298448"/>
           </a:xfrm>
           <a:prstGeom prst="roundRect">
             <a:avLst>
@@ -6645,11 +6607,11 @@
             </a:avLst>
           </a:prstGeom>
           <a:solidFill>
-            <a:srgbClr val="EAF8FE"/>
+            <a:srgbClr val="1B1B24"/>
           </a:solidFill>
           <a:ln w="12700">
             <a:solidFill>
-              <a:srgbClr val="8FD9F5"/>
+              <a:srgbClr val="2E2E3C"/>
             </a:solidFill>
           </a:ln>
           <a:effectLst/>
@@ -6676,14 +6638,58 @@
       </p:sp>
       <p:sp>
         <p:nvSpPr>
-          <p:cNvPr id="6" name="TextBox 5"/>
+          <p:cNvPr id="6" name="Rectangle 5"/>
+          <p:cNvSpPr/>
+          <p:nvPr/>
+        </p:nvSpPr>
+        <p:spPr>
+          <a:xfrm>
+            <a:off x="7132320" y="3063240"/>
+            <a:ext cx="50292" cy="1298448"/>
+          </a:xfrm>
+          <a:prstGeom prst="rect">
+            <a:avLst/>
+          </a:prstGeom>
+          <a:solidFill>
+            <a:srgbClr val="9B59B6"/>
+          </a:solidFill>
+          <a:ln>
+            <a:noFill/>
+          </a:ln>
+          <a:effectLst/>
+        </p:spPr>
+        <p:style>
+          <a:lnRef idx="1">
+            <a:schemeClr val="accent1"/>
+          </a:lnRef>
+          <a:fillRef idx="3">
+            <a:schemeClr val="accent1"/>
+          </a:fillRef>
+          <a:effectRef idx="2">
+            <a:schemeClr val="accent1"/>
+          </a:effectRef>
+          <a:fontRef idx="minor">
+            <a:schemeClr val="lt1"/>
+          </a:fontRef>
+        </p:style>
+        <p:txBody>
+          <a:bodyPr rtlCol="0" anchor="ctr"/>
+          <a:lstStyle/>
+          <a:p>
+            <a:pPr algn="ctr"/>
+          </a:p>
+        </p:txBody>
+      </p:sp>
+      <p:sp>
+        <p:nvSpPr>
+          <p:cNvPr id="7" name="TextBox 6"/>
           <p:cNvSpPr txBox="1"/>
           <p:nvPr/>
         </p:nvSpPr>
         <p:spPr>
           <a:xfrm>
-            <a:off x="3742867" y="2743200"/>
-            <a:ext cx="1996363" cy="1920240"/>
+            <a:off x="7388352" y="3227832"/>
+            <a:ext cx="3770071" cy="1005840"/>
           </a:xfrm>
           <a:prstGeom prst="rect">
             <a:avLst/>
@@ -6698,50 +6704,50 @@
           <a:p>
             <a:pPr>
               <a:spcAft>
-                <a:spcPts val="700"/>
+                <a:spcPts val="500"/>
               </a:spcAft>
-              <a:defRPr sz="1500" b="1">
-                <a:solidFill>
-                  <a:srgbClr val="121218"/>
+              <a:defRPr sz="1450" b="1">
+                <a:solidFill>
+                  <a:srgbClr val="9B59B6"/>
                 </a:solidFill>
                 <a:latin typeface="Segoe UI"/>
               </a:defRPr>
             </a:pPr>
             <a:r>
-              <a:t>Dijkstra with terrain</a:t>
+              <a:t>1 — Predict the route</a:t>
             </a:r>
           </a:p>
           <a:p>
             <a:pPr>
               <a:lnSpc>
-                <a:spcPct val="130000"/>
+                <a:spcPct val="125000"/>
               </a:lnSpc>
               <a:spcAft>
                 <a:spcPts val="0"/>
               </a:spcAft>
-              <a:defRPr sz="1200" b="0">
-                <a:solidFill>
-                  <a:srgbClr val="2C3A44"/>
+              <a:defRPr sz="1150" b="0">
+                <a:solidFill>
+                  <a:srgbClr val="C9CEDA"/>
                 </a:solidFill>
                 <a:latin typeface="Segoe UI"/>
               </a:defRPr>
             </a:pPr>
             <a:r>
-              <a:t>Mud cells costing 3 steps instead of 1, to show why BFS is really Dijkstra with every edge weighted the same.</a:t>
-            </a:r>
-          </a:p>
-        </p:txBody>
-      </p:sp>
-      <p:sp>
-        <p:nvSpPr>
-          <p:cNvPr id="7" name="Rounded Rectangle 6"/>
+              <a:t>Walk forward along your heading, following forced corridor bends. At a junction it STOPS — it cannot know which way you will turn, and guessing is worse than not guessing.</a:t>
+            </a:r>
+          </a:p>
+        </p:txBody>
+      </p:sp>
+      <p:sp>
+        <p:nvSpPr>
+          <p:cNvPr id="8" name="Rounded Rectangle 7"/>
           <p:cNvSpPr/>
           <p:nvPr/>
         </p:nvSpPr>
         <p:spPr>
           <a:xfrm>
-            <a:off x="6196431" y="2514600"/>
-            <a:ext cx="2508427" cy="2286000"/>
+            <a:off x="7132320" y="4526280"/>
+            <a:ext cx="4282135" cy="1298448"/>
           </a:xfrm>
           <a:prstGeom prst="roundRect">
             <a:avLst>
@@ -6749,11 +6755,11 @@
             </a:avLst>
           </a:prstGeom>
           <a:solidFill>
-            <a:srgbClr val="EAF8FE"/>
+            <a:srgbClr val="1B1B24"/>
           </a:solidFill>
           <a:ln w="12700">
             <a:solidFill>
-              <a:srgbClr val="8FD9F5"/>
+              <a:srgbClr val="2E2E3C"/>
             </a:solidFill>
           </a:ln>
           <a:effectLst/>
@@ -6780,85 +6786,23 @@
       </p:sp>
       <p:sp>
         <p:nvSpPr>
-          <p:cNvPr id="8" name="TextBox 7"/>
-          <p:cNvSpPr txBox="1"/>
+          <p:cNvPr id="9" name="Rectangle 8"/>
+          <p:cNvSpPr/>
           <p:nvPr/>
         </p:nvSpPr>
         <p:spPr>
           <a:xfrm>
-            <a:off x="6452463" y="2743200"/>
-            <a:ext cx="1996363" cy="1920240"/>
+            <a:off x="7132320" y="4526280"/>
+            <a:ext cx="50292" cy="1298448"/>
           </a:xfrm>
           <a:prstGeom prst="rect">
             <a:avLst/>
           </a:prstGeom>
-          <a:noFill/>
-        </p:spPr>
-        <p:txBody>
-          <a:bodyPr wrap="square" lIns="0" rIns="0" tIns="0" bIns="0">
-            <a:spAutoFit/>
-          </a:bodyPr>
-          <a:lstStyle/>
-          <a:p>
-            <a:pPr>
-              <a:spcAft>
-                <a:spcPts val="700"/>
-              </a:spcAft>
-              <a:defRPr sz="1500" b="1">
-                <a:solidFill>
-                  <a:srgbClr val="121218"/>
-                </a:solidFill>
-                <a:latin typeface="Segoe UI"/>
-              </a:defRPr>
-            </a:pPr>
-            <a:r>
-              <a:t>A better heuristic</a:t>
-            </a:r>
-          </a:p>
-          <a:p>
-            <a:pPr>
-              <a:lnSpc>
-                <a:spcPct val="130000"/>
-              </a:lnSpc>
-              <a:spcAft>
-                <a:spcPts val="0"/>
-              </a:spcAft>
-              <a:defRPr sz="1200" b="0">
-                <a:solidFill>
-                  <a:srgbClr val="2C3A44"/>
-                </a:solidFill>
-                <a:latin typeface="Segoe UI"/>
-              </a:defRPr>
-            </a:pPr>
-            <a:r>
-              <a:t>Manhattan distance is weak in a twisty maze. One that accounts for walls would widen A*'s lead — if it can be computed cheaply enough to pay for itself.</a:t>
-            </a:r>
-          </a:p>
-        </p:txBody>
-      </p:sp>
-      <p:sp>
-        <p:nvSpPr>
-          <p:cNvPr id="9" name="Rounded Rectangle 8"/>
-          <p:cNvSpPr/>
-          <p:nvPr/>
-        </p:nvSpPr>
-        <p:spPr>
-          <a:xfrm>
-            <a:off x="8906027" y="2514600"/>
-            <a:ext cx="2508427" cy="2286000"/>
-          </a:xfrm>
-          <a:prstGeom prst="roundRect">
-            <a:avLst>
-              <a:gd name="adj" fmla="val 6000"/>
-            </a:avLst>
-          </a:prstGeom>
           <a:solidFill>
-            <a:srgbClr val="EAF8FE"/>
+            <a:srgbClr val="FFD666"/>
           </a:solidFill>
-          <a:ln w="12700">
-            <a:solidFill>
-              <a:srgbClr val="8FD9F5"/>
-            </a:solidFill>
+          <a:ln>
+            <a:noFill/>
           </a:ln>
           <a:effectLst/>
         </p:spPr>
@@ -6879,7 +6823,9 @@
         <p:txBody>
           <a:bodyPr rtlCol="0" anchor="ctr"/>
           <a:lstStyle/>
-          <a:p/>
+          <a:p>
+            <a:pPr algn="ctr"/>
+          </a:p>
         </p:txBody>
       </p:sp>
       <p:sp>
@@ -6890,8 +6836,8 @@
         </p:nvSpPr>
         <p:spPr>
           <a:xfrm>
-            <a:off x="9162059" y="2743200"/>
-            <a:ext cx="1996363" cy="1920240"/>
+            <a:off x="7388352" y="4690872"/>
+            <a:ext cx="3770071" cy="1005840"/>
           </a:xfrm>
           <a:prstGeom prst="rect">
             <a:avLst/>
@@ -6906,36 +6852,36 @@
           <a:p>
             <a:pPr>
               <a:spcAft>
-                <a:spcPts val="700"/>
+                <a:spcPts val="500"/>
               </a:spcAft>
-              <a:defRPr sz="1500" b="1">
-                <a:solidFill>
-                  <a:srgbClr val="121218"/>
+              <a:defRPr sz="1450" b="1">
+                <a:solidFill>
+                  <a:srgbClr val="FFD666"/>
                 </a:solidFill>
                 <a:latin typeface="Segoe UI"/>
               </a:defRPr>
             </a:pPr>
             <a:r>
-              <a:t>Fog of war</a:t>
+              <a:t>2 — Find the cut-off</a:t>
             </a:r>
           </a:p>
           <a:p>
             <a:pPr>
               <a:lnSpc>
-                <a:spcPct val="130000"/>
+                <a:spcPct val="125000"/>
               </a:lnSpc>
               <a:spcAft>
                 <a:spcPts val="0"/>
               </a:spcAft>
-              <a:defRPr sz="1200" b="0">
-                <a:solidFill>
-                  <a:srgbClr val="2C3A44"/>
+              <a:defRPr sz="1150" b="0">
+                <a:solidFill>
+                  <a:srgbClr val="C9CEDA"/>
                 </a:solidFill>
                 <a:latin typeface="Segoe UI"/>
               </a:defRPr>
             </a:pPr>
             <a:r>
-              <a:t>Limit the player's vision radius, so the maze has to be learned rather than read off the screen in one glance.</a:t>
+              <a:t>One flood fill gives its distance to every cell. It takes the deepest cell on your route it can reach no later than you — the yellow box.</a:t>
             </a:r>
           </a:p>
         </p:txBody>
@@ -6948,8 +6894,8 @@
         </p:nvSpPr>
         <p:spPr>
           <a:xfrm>
-            <a:off x="777240" y="5349240"/>
-            <a:ext cx="10637215" cy="548640"/>
+            <a:off x="7132320" y="5943600"/>
+            <a:ext cx="4282135" cy="457200"/>
           </a:xfrm>
           <a:prstGeom prst="rect">
             <a:avLst/>
@@ -6963,34 +6909,60 @@
           <a:lstStyle/>
           <a:p>
             <a:pPr>
+              <a:lnSpc>
+                <a:spcPct val="125000"/>
+              </a:lnSpc>
               <a:spcAft>
-                <a:spcPts val="600"/>
+                <a:spcPts val="0"/>
               </a:spcAft>
-              <a:defRPr sz="1600" b="1">
-                <a:solidFill>
-                  <a:srgbClr val="121218"/>
-                </a:solidFill>
-                <a:latin typeface="Consolas"/>
+              <a:defRPr sz="1100" b="0">
+                <a:solidFill>
+                  <a:srgbClr val="6A7179"/>
+                </a:solidFill>
+                <a:latin typeface="Segoe UI"/>
               </a:defRPr>
             </a:pPr>
             <a:r>
-              <a:t>github.com/Hyperval/maze-runner</a:t>
-            </a:r>
-          </a:p>
+              <a:t>Costs ~721 cells of thinking per step against BFS's 328. It pays for the ability.</a:t>
+            </a:r>
+          </a:p>
+        </p:txBody>
+      </p:sp>
+      <p:sp>
+        <p:nvSpPr>
+          <p:cNvPr id="12" name="TextBox 11"/>
+          <p:cNvSpPr txBox="1"/>
+          <p:nvPr/>
+        </p:nvSpPr>
+        <p:spPr>
+          <a:xfrm>
+            <a:off x="777240" y="6199632"/>
+            <a:ext cx="10637215" cy="411480"/>
+          </a:xfrm>
+          <a:prstGeom prst="rect">
+            <a:avLst/>
+          </a:prstGeom>
+          <a:noFill/>
+        </p:spPr>
+        <p:txBody>
+          <a:bodyPr wrap="square" lIns="0" rIns="0" tIns="0" bIns="0">
+            <a:spAutoFit/>
+          </a:bodyPr>
+          <a:lstStyle/>
           <a:p>
             <a:pPr>
               <a:spcAft>
                 <a:spcPts val="0"/>
               </a:spcAft>
-              <a:defRPr sz="1600" b="0">
-                <a:solidFill>
-                  <a:srgbClr val="15506B"/>
+              <a:defRPr sz="1050" b="0">
+                <a:solidFill>
+                  <a:srgbClr val="6A7179"/>
                 </a:solidFill>
                 <a:latin typeface="Segoe UI"/>
               </a:defRPr>
             </a:pPr>
             <a:r>
-              <a:t>Thank you — questions welcome.</a:t>
+              <a:t>Still ahead: enemies that cooperate to pincer  ·  Dijkstra with weighted terrain  ·  fog of war        github.com/Hyperval/maze-runner</a:t>
             </a:r>
           </a:p>
         </p:txBody>

</xml_diff>